<commit_message>
Pitch deck: Mittelverwendung auf 70/15/15 umgestellt
Engineering 70 % (350k), Go-to-Market 15 % (75k), Infrastructure &
Compliance 15 % (75k). Delivery als eigener Posten entfaellt, die
Delivery-Kapazitaet ist in die Engineering-Beschreibung gezogen, damit die
Slide die Frage "wer liefert dann aus" nicht offen laesst.

Die Ask-Slide ist damit von vier auf drei Spalten umgebaut: verbleibende
Spalten auf das 3-Spalten-Raster (54,7 / 349,2 / 643,7 mit Breite 259,9),
vertikale Trenner auf 332,6 und 627,1, ein Trenner entfernt.

Co-Authored-By: Claude Opus 5 <noreply@anthropic.com>
Claude-Session: https://claude.ai/code/session_01JZsVLFh6S3QVvWf8D6qeKq
</commit_message>
<xml_diff>
--- a/pitch-deck/AthenaRun_Pitch_Deck_15_Slides.pptx
+++ b/pitch-deck/AthenaRun_Pitch_Deck_15_Slides.pptx
@@ -8728,8 +8728,8 @@
         </p:nvSpPr>
         <p:spPr>
           <a:xfrm>
-            <a:off x="694943" y="2560320"/>
-            <a:ext cx="2468882" cy="127001"/>
+            <a:off x="694690" y="2560320"/>
+            <a:ext cx="3300730" cy="127001"/>
           </a:xfrm>
           <a:prstGeom prst="rect">
             <a:avLst/>
@@ -8776,8 +8776,8 @@
         </p:nvSpPr>
         <p:spPr>
           <a:xfrm>
-            <a:off x="694943" y="2798064"/>
-            <a:ext cx="2468882" cy="254001"/>
+            <a:off x="694690" y="2798064"/>
+            <a:ext cx="3300730" cy="254001"/>
           </a:xfrm>
           <a:prstGeom prst="rect">
             <a:avLst/>
@@ -8814,7 +8814,7 @@
           <a:p>
             <a:pPr/>
             <a:r>
-              <a:t>40% · €200k</a:t>
+              <a:t>70% · €350k</a:t>
             </a:r>
           </a:p>
         </p:txBody>
@@ -8827,8 +8827,8 @@
         </p:nvSpPr>
         <p:spPr>
           <a:xfrm>
-            <a:off x="694943" y="3419855"/>
-            <a:ext cx="2468882" cy="584200"/>
+            <a:off x="694690" y="3419855"/>
+            <a:ext cx="3300730" cy="762000"/>
           </a:xfrm>
           <a:prstGeom prst="rect">
             <a:avLst/>
@@ -8865,21 +8865,21 @@
           <a:p>
             <a:pPr/>
             <a:r>
-              <a:t>Platform hardening, the engineering library, the autonomous build pipeline.</a:t>
-            </a:r>
-          </a:p>
-        </p:txBody>
-      </p:sp>
-      <p:sp>
-        <p:nvSpPr>
-          <p:cNvPr id="276" name="Google Shape;426;p22"/>
-          <p:cNvSpPr txBox="1"/>
-          <p:nvPr/>
-        </p:nvSpPr>
-        <p:spPr>
-          <a:xfrm>
-            <a:off x="3401567" y="2560320"/>
-            <a:ext cx="2468882" cy="127001"/>
+              <a:t>Platform hardening, the engineering library, the autonomous build pipeline, and the engineers who run the first builds.</a:t>
+            </a:r>
+          </a:p>
+        </p:txBody>
+      </p:sp>
+      <p:sp>
+        <p:nvSpPr>
+          <p:cNvPr id="279" name="Google Shape;429;p22"/>
+          <p:cNvSpPr txBox="1"/>
+          <p:nvPr/>
+        </p:nvSpPr>
+        <p:spPr>
+          <a:xfrm>
+            <a:off x="4434840" y="2560320"/>
+            <a:ext cx="3300730" cy="127001"/>
           </a:xfrm>
           <a:prstGeom prst="rect">
             <a:avLst/>
@@ -8913,21 +8913,21 @@
           <a:p>
             <a:pPr/>
             <a:r>
-              <a:t>DELIVERY</a:t>
-            </a:r>
-          </a:p>
-        </p:txBody>
-      </p:sp>
-      <p:sp>
-        <p:nvSpPr>
-          <p:cNvPr id="277" name="Google Shape;427;p22"/>
-          <p:cNvSpPr txBox="1"/>
-          <p:nvPr/>
-        </p:nvSpPr>
-        <p:spPr>
-          <a:xfrm>
-            <a:off x="3401567" y="2798064"/>
-            <a:ext cx="2468882" cy="254001"/>
+              <a:t>GO-TO-MARKET</a:t>
+            </a:r>
+          </a:p>
+        </p:txBody>
+      </p:sp>
+      <p:sp>
+        <p:nvSpPr>
+          <p:cNvPr id="280" name="Google Shape;430;p22"/>
+          <p:cNvSpPr txBox="1"/>
+          <p:nvPr/>
+        </p:nvSpPr>
+        <p:spPr>
+          <a:xfrm>
+            <a:off x="4434840" y="2798064"/>
+            <a:ext cx="3300730" cy="254001"/>
           </a:xfrm>
           <a:prstGeom prst="rect">
             <a:avLst/>
@@ -8964,21 +8964,21 @@
           <a:p>
             <a:pPr/>
             <a:r>
-              <a:t>25% · €125k</a:t>
-            </a:r>
-          </a:p>
-        </p:txBody>
-      </p:sp>
-      <p:sp>
-        <p:nvSpPr>
-          <p:cNvPr id="278" name="Google Shape;428;p22"/>
-          <p:cNvSpPr txBox="1"/>
-          <p:nvPr/>
-        </p:nvSpPr>
-        <p:spPr>
-          <a:xfrm>
-            <a:off x="3401567" y="3419855"/>
-            <a:ext cx="2468882" cy="584200"/>
+              <a:t>15% · €75k</a:t>
+            </a:r>
+          </a:p>
+        </p:txBody>
+      </p:sp>
+      <p:sp>
+        <p:nvSpPr>
+          <p:cNvPr id="281" name="Google Shape;431;p22"/>
+          <p:cNvSpPr txBox="1"/>
+          <p:nvPr/>
+        </p:nvSpPr>
+        <p:spPr>
+          <a:xfrm>
+            <a:off x="4434840" y="3419855"/>
+            <a:ext cx="3300730" cy="762000"/>
           </a:xfrm>
           <a:prstGeom prst="rect">
             <a:avLst/>
@@ -9015,21 +9015,21 @@
           <a:p>
             <a:pPr/>
             <a:r>
-              <a:t>Solution engineers to take the first customers through all six gates.</a:t>
-            </a:r>
-          </a:p>
-        </p:txBody>
-      </p:sp>
-      <p:sp>
-        <p:nvSpPr>
-          <p:cNvPr id="279" name="Google Shape;429;p22"/>
-          <p:cNvSpPr txBox="1"/>
-          <p:nvPr/>
-        </p:nvSpPr>
-        <p:spPr>
-          <a:xfrm>
-            <a:off x="6108191" y="2560320"/>
-            <a:ext cx="2468882" cy="127001"/>
+              <a:t>Convert the seven LOIs, activate the channel partner, run outbound on Baru.</a:t>
+            </a:r>
+          </a:p>
+        </p:txBody>
+      </p:sp>
+      <p:sp>
+        <p:nvSpPr>
+          <p:cNvPr id="282" name="Google Shape;432;p22"/>
+          <p:cNvSpPr txBox="1"/>
+          <p:nvPr/>
+        </p:nvSpPr>
+        <p:spPr>
+          <a:xfrm>
+            <a:off x="8174990" y="2560320"/>
+            <a:ext cx="3300730" cy="127001"/>
           </a:xfrm>
           <a:prstGeom prst="rect">
             <a:avLst/>
@@ -9063,21 +9063,21 @@
           <a:p>
             <a:pPr/>
             <a:r>
-              <a:t>GO-TO-MARKET</a:t>
-            </a:r>
-          </a:p>
-        </p:txBody>
-      </p:sp>
-      <p:sp>
-        <p:nvSpPr>
-          <p:cNvPr id="280" name="Google Shape;430;p22"/>
-          <p:cNvSpPr txBox="1"/>
-          <p:nvPr/>
-        </p:nvSpPr>
-        <p:spPr>
-          <a:xfrm>
-            <a:off x="6108191" y="2798064"/>
-            <a:ext cx="2468882" cy="254001"/>
+              <a:t>INFRASTRUCTURE &amp; COMPLIANCE</a:t>
+            </a:r>
+          </a:p>
+        </p:txBody>
+      </p:sp>
+      <p:sp>
+        <p:nvSpPr>
+          <p:cNvPr id="283" name="Google Shape;433;p22"/>
+          <p:cNvSpPr txBox="1"/>
+          <p:nvPr/>
+        </p:nvSpPr>
+        <p:spPr>
+          <a:xfrm>
+            <a:off x="8174990" y="2798064"/>
+            <a:ext cx="3300730" cy="254001"/>
           </a:xfrm>
           <a:prstGeom prst="rect">
             <a:avLst/>
@@ -9114,21 +9114,21 @@
           <a:p>
             <a:pPr/>
             <a:r>
-              <a:t>25% · €125k</a:t>
-            </a:r>
-          </a:p>
-        </p:txBody>
-      </p:sp>
-      <p:sp>
-        <p:nvSpPr>
-          <p:cNvPr id="281" name="Google Shape;431;p22"/>
-          <p:cNvSpPr txBox="1"/>
-          <p:nvPr/>
-        </p:nvSpPr>
-        <p:spPr>
-          <a:xfrm>
-            <a:off x="6108191" y="3419855"/>
-            <a:ext cx="2468882" cy="584200"/>
+              <a:t>15% · €75k</a:t>
+            </a:r>
+          </a:p>
+        </p:txBody>
+      </p:sp>
+      <p:sp>
+        <p:nvSpPr>
+          <p:cNvPr id="284" name="Google Shape;434;p22"/>
+          <p:cNvSpPr txBox="1"/>
+          <p:nvPr/>
+        </p:nvSpPr>
+        <p:spPr>
+          <a:xfrm>
+            <a:off x="8174990" y="3419855"/>
+            <a:ext cx="3300730" cy="762000"/>
           </a:xfrm>
           <a:prstGeom prst="rect">
             <a:avLst/>
@@ -9165,156 +9165,6 @@
           <a:p>
             <a:pPr/>
             <a:r>
-              <a:t>Convert the seven LOIs, activate the channel partner, run outbound on Baru.</a:t>
-            </a:r>
-          </a:p>
-        </p:txBody>
-      </p:sp>
-      <p:sp>
-        <p:nvSpPr>
-          <p:cNvPr id="282" name="Google Shape;432;p22"/>
-          <p:cNvSpPr txBox="1"/>
-          <p:nvPr/>
-        </p:nvSpPr>
-        <p:spPr>
-          <a:xfrm>
-            <a:off x="8814816" y="2560320"/>
-            <a:ext cx="2468881" cy="127001"/>
-          </a:xfrm>
-          <a:prstGeom prst="rect">
-            <a:avLst/>
-          </a:prstGeom>
-          <a:ln w="12700">
-            <a:miter lim="400000"/>
-          </a:ln>
-          <a:extLst>
-            <a:ext uri="{C572A759-6A51-4108-AA02-DFA0A04FC94B}">
-              <ma14:wrappingTextBoxFlag xmlns:ma14="http://schemas.microsoft.com/office/mac/drawingml/2011/main" val="1"/>
-            </a:ext>
-          </a:extLst>
-        </p:spPr>
-        <p:txBody>
-          <a:bodyPr lIns="0" tIns="0" rIns="0" bIns="0">
-            <a:spAutoFit/>
-          </a:bodyPr>
-          <a:lstStyle>
-            <a:lvl1pPr>
-              <a:defRPr sz="900">
-                <a:solidFill>
-                  <a:srgbClr val="9A9AA2"/>
-                </a:solidFill>
-                <a:latin typeface="Courier New"/>
-                <a:ea typeface="Courier New"/>
-                <a:cs typeface="Courier New"/>
-                <a:sym typeface="Courier New"/>
-              </a:defRPr>
-            </a:lvl1pPr>
-          </a:lstStyle>
-          <a:p>
-            <a:pPr/>
-            <a:r>
-              <a:t>COMPLIANCE &amp; INFRA</a:t>
-            </a:r>
-          </a:p>
-        </p:txBody>
-      </p:sp>
-      <p:sp>
-        <p:nvSpPr>
-          <p:cNvPr id="283" name="Google Shape;433;p22"/>
-          <p:cNvSpPr txBox="1"/>
-          <p:nvPr/>
-        </p:nvSpPr>
-        <p:spPr>
-          <a:xfrm>
-            <a:off x="8814816" y="2798064"/>
-            <a:ext cx="2468881" cy="254001"/>
-          </a:xfrm>
-          <a:prstGeom prst="rect">
-            <a:avLst/>
-          </a:prstGeom>
-          <a:ln w="12700">
-            <a:miter lim="400000"/>
-          </a:ln>
-          <a:extLst>
-            <a:ext uri="{C572A759-6A51-4108-AA02-DFA0A04FC94B}">
-              <ma14:wrappingTextBoxFlag xmlns:ma14="http://schemas.microsoft.com/office/mac/drawingml/2011/main" val="1"/>
-            </a:ext>
-          </a:extLst>
-        </p:spPr>
-        <p:txBody>
-          <a:bodyPr lIns="0" tIns="0" rIns="0" bIns="0">
-            <a:spAutoFit/>
-          </a:bodyPr>
-          <a:lstStyle>
-            <a:lvl1pPr>
-              <a:lnSpc>
-                <a:spcPct val="115000"/>
-              </a:lnSpc>
-              <a:defRPr b="1" sz="1700">
-                <a:solidFill>
-                  <a:srgbClr val="ECECEE"/>
-                </a:solidFill>
-                <a:latin typeface="Poppins"/>
-                <a:ea typeface="Poppins"/>
-                <a:cs typeface="Poppins"/>
-                <a:sym typeface="Poppins"/>
-              </a:defRPr>
-            </a:lvl1pPr>
-          </a:lstStyle>
-          <a:p>
-            <a:pPr/>
-            <a:r>
-              <a:t>10% · €50k</a:t>
-            </a:r>
-          </a:p>
-        </p:txBody>
-      </p:sp>
-      <p:sp>
-        <p:nvSpPr>
-          <p:cNvPr id="284" name="Google Shape;434;p22"/>
-          <p:cNvSpPr txBox="1"/>
-          <p:nvPr/>
-        </p:nvSpPr>
-        <p:spPr>
-          <a:xfrm>
-            <a:off x="8814816" y="3419855"/>
-            <a:ext cx="2468881" cy="584200"/>
-          </a:xfrm>
-          <a:prstGeom prst="rect">
-            <a:avLst/>
-          </a:prstGeom>
-          <a:ln w="12700">
-            <a:miter lim="400000"/>
-          </a:ln>
-          <a:extLst>
-            <a:ext uri="{C572A759-6A51-4108-AA02-DFA0A04FC94B}">
-              <ma14:wrappingTextBoxFlag xmlns:ma14="http://schemas.microsoft.com/office/mac/drawingml/2011/main" val="1"/>
-            </a:ext>
-          </a:extLst>
-        </p:spPr>
-        <p:txBody>
-          <a:bodyPr lIns="0" tIns="0" rIns="0" bIns="0">
-            <a:spAutoFit/>
-          </a:bodyPr>
-          <a:lstStyle>
-            <a:lvl1pPr>
-              <a:lnSpc>
-                <a:spcPct val="135000"/>
-              </a:lnSpc>
-              <a:defRPr sz="1100">
-                <a:solidFill>
-                  <a:srgbClr val="9A9AA2"/>
-                </a:solidFill>
-                <a:latin typeface="Poppins"/>
-                <a:ea typeface="Poppins"/>
-                <a:cs typeface="Poppins"/>
-                <a:sym typeface="Poppins"/>
-              </a:defRPr>
-            </a:lvl1pPr>
-          </a:lstStyle>
-          <a:p>
-            <a:pPr/>
-            <a:r>
               <a:t>EU hosting, audit tooling, ISO 27001 and EU AI Act readiness.</a:t>
             </a:r>
           </a:p>
@@ -9328,7 +9178,7 @@
         </p:nvSpPr>
         <p:spPr>
           <a:xfrm>
-            <a:off x="3162959" y="2560320"/>
+            <a:off x="4224020" y="2560320"/>
             <a:ext cx="12701" cy="1444753"/>
           </a:xfrm>
           <a:prstGeom prst="rect">
@@ -9364,43 +9214,7 @@
         </p:nvSpPr>
         <p:spPr>
           <a:xfrm>
-            <a:off x="5869583" y="2560320"/>
-            <a:ext cx="12701" cy="1444753"/>
-          </a:xfrm>
-          <a:prstGeom prst="rect">
-            <a:avLst/>
-          </a:prstGeom>
-          <a:solidFill>
-            <a:srgbClr val="2B2B2D"/>
-          </a:solidFill>
-          <a:ln w="12700">
-            <a:miter lim="400000"/>
-          </a:ln>
-        </p:spPr>
-        <p:txBody>
-          <a:bodyPr lIns="0" tIns="0" rIns="0" bIns="0" anchor="ctr"/>
-          <a:lstStyle/>
-          <a:p>
-            <a:pPr algn="ctr">
-              <a:defRPr sz="1800">
-                <a:latin typeface="Calibri"/>
-                <a:ea typeface="Calibri"/>
-                <a:cs typeface="Calibri"/>
-                <a:sym typeface="Calibri"/>
-              </a:defRPr>
-            </a:pPr>
-          </a:p>
-        </p:txBody>
-      </p:sp>
-      <p:sp>
-        <p:nvSpPr>
-          <p:cNvPr id="287" name="Google Shape;437;p22"/>
-          <p:cNvSpPr/>
-          <p:nvPr/>
-        </p:nvSpPr>
-        <p:spPr>
-          <a:xfrm>
-            <a:off x="8576207" y="2560320"/>
+            <a:off x="7964170" y="2560320"/>
             <a:ext cx="12701" cy="1444753"/>
           </a:xfrm>
           <a:prstGeom prst="rect">

</xml_diff>